<commit_message>
Add lesson quizzes to all course decks
</commit_message>
<xml_diff>
--- a/decks/01-model-gateway.pptx
+++ b/decks/01-model-gateway.pptx
@@ -2,19 +2,21 @@
 <file path=ppt/presentation.xml><?xml version="1.0" encoding="utf-8"?>
 <p:presentation xmlns:p="http://schemas.openxmlformats.org/presentationml/2006/main">
   <p:sldMasterIdLst>
-    <p:sldMasterId xmlns:r="http://schemas.openxmlformats.org/officeDocument/2006/relationships" id="2147483648" r:id="R41683231b11e4910"/>
+    <p:sldMasterId xmlns:r="http://schemas.openxmlformats.org/officeDocument/2006/relationships" id="2147483648" r:id="R5e730159e7e04962"/>
   </p:sldMasterIdLst>
   <p:notesMasterIdLst>
-    <p:notesMasterId xmlns:r="http://schemas.openxmlformats.org/officeDocument/2006/relationships" r:id="Rde1b12a7805044a1"/>
+    <p:notesMasterId xmlns:r="http://schemas.openxmlformats.org/officeDocument/2006/relationships" r:id="R436dee3bc4a74dab"/>
   </p:notesMasterIdLst>
   <p:sldIdLst>
-    <p:sldId xmlns:r="http://schemas.openxmlformats.org/officeDocument/2006/relationships" id="256" r:id="Rce3885c9e95d48f9"/>
-    <p:sldId xmlns:r="http://schemas.openxmlformats.org/officeDocument/2006/relationships" id="257" r:id="R47cdc41766a84a13"/>
-    <p:sldId xmlns:r="http://schemas.openxmlformats.org/officeDocument/2006/relationships" id="258" r:id="R3081b99bd24646c6"/>
-    <p:sldId xmlns:r="http://schemas.openxmlformats.org/officeDocument/2006/relationships" id="259" r:id="R2b0bd4dff12b452b"/>
-    <p:sldId xmlns:r="http://schemas.openxmlformats.org/officeDocument/2006/relationships" id="260" r:id="R3b71dcb289014f65"/>
-    <p:sldId xmlns:r="http://schemas.openxmlformats.org/officeDocument/2006/relationships" id="261" r:id="R8f4c3062c45a4ae4"/>
-    <p:sldId xmlns:r="http://schemas.openxmlformats.org/officeDocument/2006/relationships" id="262" r:id="R0801619bc42041a5"/>
+    <p:sldId xmlns:r="http://schemas.openxmlformats.org/officeDocument/2006/relationships" id="256" r:id="Rd3165d101bf84a70"/>
+    <p:sldId xmlns:r="http://schemas.openxmlformats.org/officeDocument/2006/relationships" id="257" r:id="R85d6e5e467224f40"/>
+    <p:sldId xmlns:r="http://schemas.openxmlformats.org/officeDocument/2006/relationships" id="258" r:id="Rda0d5255683a429e"/>
+    <p:sldId xmlns:r="http://schemas.openxmlformats.org/officeDocument/2006/relationships" id="259" r:id="Rf439c962175c493f"/>
+    <p:sldId xmlns:r="http://schemas.openxmlformats.org/officeDocument/2006/relationships" id="260" r:id="R5fce838a1c8a478a"/>
+    <p:sldId xmlns:r="http://schemas.openxmlformats.org/officeDocument/2006/relationships" id="261" r:id="R6fe314478f914e65"/>
+    <p:sldId xmlns:r="http://schemas.openxmlformats.org/officeDocument/2006/relationships" id="262" r:id="R76e80cdc47e346b3"/>
+    <p:sldId xmlns:r="http://schemas.openxmlformats.org/officeDocument/2006/relationships" id="263" r:id="Rd5d34eb10cb043b2"/>
+    <p:sldId xmlns:r="http://schemas.openxmlformats.org/officeDocument/2006/relationships" id="264" r:id="R844f16d6b29749ff"/>
   </p:sldIdLst>
   <p:sldSz cx="15240000" cy="8572500"/>
   <p:notesSz cx="6858000" cy="9144000"/>
@@ -1058,6 +1060,196 @@
 </p:notes>
 </file>
 
+<file path=ppt/notesSlides/notesSlide8.xml><?xml version="1.0" encoding="utf-8"?>
+<p:notes xmlns:p="http://schemas.openxmlformats.org/presentationml/2006/main">
+  <p:cSld>
+    <p:spTree>
+      <p:nvGrpSpPr>
+        <p:cNvPr id="1" name=""/>
+        <p:cNvGrpSpPr/>
+        <p:nvPr/>
+      </p:nvGrpSpPr>
+      <p:grpSpPr>
+        <a:xfrm xmlns:a="http://schemas.openxmlformats.org/drawingml/2006/main"/>
+      </p:grpSpPr>
+      <p:sp>
+        <p:nvSpPr>
+          <p:cNvPr id="2" name="Slide Image Placeholder 1"/>
+          <p:cNvSpPr>
+            <a:spLocks xmlns:a="http://schemas.openxmlformats.org/drawingml/2006/main" noGrp="1"/>
+          </p:cNvSpPr>
+          <p:nvPr>
+            <p:ph type="sldImg" idx="0"/>
+          </p:nvPr>
+        </p:nvSpPr>
+        <p:spPr/>
+      </p:sp>
+      <p:sp>
+        <p:nvSpPr>
+          <p:cNvPr id="3" name="Notes Placeholder 2"/>
+          <p:cNvSpPr>
+            <a:spLocks xmlns:a="http://schemas.openxmlformats.org/drawingml/2006/main" noGrp="1"/>
+          </p:cNvSpPr>
+          <p:nvPr>
+            <p:ph type="body" idx="1"/>
+          </p:nvPr>
+        </p:nvSpPr>
+        <p:spPr/>
+        <p:txBody>
+          <a:bodyPr xmlns:a="http://schemas.openxmlformats.org/drawingml/2006/main"/>
+          <a:lstStyle xmlns:a="http://schemas.openxmlformats.org/drawingml/2006/main"/>
+          <a:p xmlns:a="http://schemas.openxmlformats.org/drawingml/2006/main">
+            <a:r>
+              <a:t>Instructor purpose: Check the three core decisions before the lesson closes.</a:t>
+            </a:r>
+          </a:p>
+          <a:p xmlns:a="http://schemas.openxmlformats.org/drawingml/2006/main">
+            <a:r>
+              <a:t>Planned timing: 3 minutes.</a:t>
+            </a:r>
+          </a:p>
+          <a:p xmlns:a="http://schemas.openxmlformats.org/drawingml/2006/main">
+            <a:r>
+              <a:t>Facilitation: ask for one letter per question.</a:t>
+            </a:r>
+          </a:p>
+          <a:p xmlns:a="http://schemas.openxmlformats.org/drawingml/2006/main">
+            <a:r>
+              <a:t>[Sources]</a:t>
+            </a:r>
+          </a:p>
+          <a:p xmlns:a="http://schemas.openxmlformats.org/drawingml/2006/main">
+            <a:r>
+              <a:t>- chapters/01-model-gateway.md</a:t>
+            </a:r>
+          </a:p>
+          <a:p xmlns:a="http://schemas.openxmlformats.org/drawingml/2006/main">
+            <a:r>
+              <a:t>[/Sources]</a:t>
+            </a:r>
+          </a:p>
+        </p:txBody>
+      </p:sp>
+      <p:sp>
+        <p:nvSpPr>
+          <p:cNvPr id="4" name="Slide Number Placeholder 3"/>
+          <p:cNvSpPr>
+            <a:spLocks xmlns:a="http://schemas.openxmlformats.org/drawingml/2006/main" noGrp="1"/>
+          </p:cNvSpPr>
+          <p:nvPr>
+            <p:ph type="sldNum" idx="5"/>
+          </p:nvPr>
+        </p:nvSpPr>
+        <p:spPr/>
+        <p:txBody>
+          <a:bodyPr xmlns:a="http://schemas.openxmlformats.org/drawingml/2006/main"/>
+          <a:lstStyle xmlns:a="http://schemas.openxmlformats.org/drawingml/2006/main"/>
+          <a:p xmlns:a="http://schemas.openxmlformats.org/drawingml/2006/main"/>
+        </p:txBody>
+      </p:sp>
+    </p:spTree>
+  </p:cSld>
+  <p:clrMapOvr>
+    <a:masterClrMapping xmlns:a="http://schemas.openxmlformats.org/drawingml/2006/main"/>
+  </p:clrMapOvr>
+</p:notes>
+</file>
+
+<file path=ppt/notesSlides/notesSlide9.xml><?xml version="1.0" encoding="utf-8"?>
+<p:notes xmlns:p="http://schemas.openxmlformats.org/presentationml/2006/main">
+  <p:cSld>
+    <p:spTree>
+      <p:nvGrpSpPr>
+        <p:cNvPr id="1" name=""/>
+        <p:cNvGrpSpPr/>
+        <p:nvPr/>
+      </p:nvGrpSpPr>
+      <p:grpSpPr>
+        <a:xfrm xmlns:a="http://schemas.openxmlformats.org/drawingml/2006/main"/>
+      </p:grpSpPr>
+      <p:sp>
+        <p:nvSpPr>
+          <p:cNvPr id="2" name="Slide Image Placeholder 1"/>
+          <p:cNvSpPr>
+            <a:spLocks xmlns:a="http://schemas.openxmlformats.org/drawingml/2006/main" noGrp="1"/>
+          </p:cNvSpPr>
+          <p:nvPr>
+            <p:ph type="sldImg" idx="0"/>
+          </p:nvPr>
+        </p:nvSpPr>
+        <p:spPr/>
+      </p:sp>
+      <p:sp>
+        <p:nvSpPr>
+          <p:cNvPr id="3" name="Notes Placeholder 2"/>
+          <p:cNvSpPr>
+            <a:spLocks xmlns:a="http://schemas.openxmlformats.org/drawingml/2006/main" noGrp="1"/>
+          </p:cNvSpPr>
+          <p:nvPr>
+            <p:ph type="body" idx="1"/>
+          </p:nvPr>
+        </p:nvSpPr>
+        <p:spPr/>
+        <p:txBody>
+          <a:bodyPr xmlns:a="http://schemas.openxmlformats.org/drawingml/2006/main"/>
+          <a:lstStyle xmlns:a="http://schemas.openxmlformats.org/drawingml/2006/main"/>
+          <a:p xmlns:a="http://schemas.openxmlformats.org/drawingml/2006/main">
+            <a:r>
+              <a:t>Instructor purpose: Correct the quiz and restate the practical rule behind each answer.</a:t>
+            </a:r>
+          </a:p>
+          <a:p xmlns:a="http://schemas.openxmlformats.org/drawingml/2006/main">
+            <a:r>
+              <a:t>Planned timing: 3 minutes.</a:t>
+            </a:r>
+          </a:p>
+          <a:p xmlns:a="http://schemas.openxmlformats.org/drawingml/2006/main">
+            <a:r>
+              <a:t>Facilitation: ask learners to explain each rule in their own words.</a:t>
+            </a:r>
+          </a:p>
+          <a:p xmlns:a="http://schemas.openxmlformats.org/drawingml/2006/main">
+            <a:r>
+              <a:t>[Sources]</a:t>
+            </a:r>
+          </a:p>
+          <a:p xmlns:a="http://schemas.openxmlformats.org/drawingml/2006/main">
+            <a:r>
+              <a:t>- chapters/01-model-gateway.md</a:t>
+            </a:r>
+          </a:p>
+          <a:p xmlns:a="http://schemas.openxmlformats.org/drawingml/2006/main">
+            <a:r>
+              <a:t>[/Sources]</a:t>
+            </a:r>
+          </a:p>
+        </p:txBody>
+      </p:sp>
+      <p:sp>
+        <p:nvSpPr>
+          <p:cNvPr id="4" name="Slide Number Placeholder 3"/>
+          <p:cNvSpPr>
+            <a:spLocks xmlns:a="http://schemas.openxmlformats.org/drawingml/2006/main" noGrp="1"/>
+          </p:cNvSpPr>
+          <p:nvPr>
+            <p:ph type="sldNum" idx="5"/>
+          </p:nvPr>
+        </p:nvSpPr>
+        <p:spPr/>
+        <p:txBody>
+          <a:bodyPr xmlns:a="http://schemas.openxmlformats.org/drawingml/2006/main"/>
+          <a:lstStyle xmlns:a="http://schemas.openxmlformats.org/drawingml/2006/main"/>
+          <a:p xmlns:a="http://schemas.openxmlformats.org/drawingml/2006/main"/>
+        </p:txBody>
+      </p:sp>
+    </p:spTree>
+  </p:cSld>
+  <p:clrMapOvr>
+    <a:masterClrMapping xmlns:a="http://schemas.openxmlformats.org/drawingml/2006/main"/>
+  </p:clrMapOvr>
+</p:notes>
+</file>
+
 <file path=ppt/slideLayouts/slideLayout1.xml><?xml version="1.0" encoding="utf-8"?>
 <p:sldLayout xmlns:p="http://schemas.openxmlformats.org/presentationml/2006/main" type="title">
   <p:cSld name="Title Slide">
@@ -1096,7 +1288,7 @@
   </p:cSld>
   <p:clrMap bg1="lt1" tx1="dk1" bg2="lt2" tx2="dk2" accent1="accent1" accent2="accent2" accent3="accent3" accent4="accent4" accent5="accent5" accent6="accent6" hlink="hlink" folHlink="folHlink"/>
   <p:sldLayoutIdLst>
-    <p:sldLayoutId xmlns:r="http://schemas.openxmlformats.org/officeDocument/2006/relationships" id="2147483649" r:id="R0efea88707184c93"/>
+    <p:sldLayoutId xmlns:r="http://schemas.openxmlformats.org/officeDocument/2006/relationships" id="2147483649" r:id="R28fe8e2ba2524cfb"/>
   </p:sldLayoutIdLst>
   <p:txStyles>
     <p:titleStyle>
@@ -8744,6 +8936,1300 @@
 </p:sld>
 </file>
 
+<file path=ppt/slides/slide8.xml><?xml version="1.0" encoding="utf-8"?>
+<p:sld xmlns:p="http://schemas.openxmlformats.org/presentationml/2006/main">
+  <p:cSld>
+    <p:bg>
+      <p:bgPr>
+        <a:solidFill xmlns:a="http://schemas.openxmlformats.org/drawingml/2006/main">
+          <a:srgbClr val="F5F5F5"/>
+        </a:solidFill>
+      </p:bgPr>
+    </p:bg>
+    <p:spTree>
+      <p:nvGrpSpPr>
+        <p:cNvPr id="1" name=""/>
+        <p:cNvGrpSpPr/>
+        <p:nvPr/>
+      </p:nvGrpSpPr>
+      <p:grpSpPr>
+        <a:xfrm xmlns:a="http://schemas.openxmlformats.org/drawingml/2006/main"/>
+      </p:grpSpPr>
+      <p:sp>
+        <p:nvSpPr>
+          <p:cNvPr id="7" name="">
+            <a:extLst xmlns:a="http://schemas.openxmlformats.org/drawingml/2006/main">
+              <a:ext uri="{FF2B5EF4-FFF2-40B4-BE49-F238E27FC236}">
+                <a16:creationId xmlns:a16="http://schemas.microsoft.com/office/drawing/2014/main" id="{1291AC7A-C390-4918-960F-B031B7C93A63}"/>
+              </a:ext>
+            </a:extLst>
+          </p:cNvPr>
+          <p:cNvSpPr>
+            <a:spLocks xmlns:a="http://schemas.openxmlformats.org/drawingml/2006/main" noGrp="1"/>
+          </p:cNvSpPr>
+          <p:nvPr/>
+        </p:nvSpPr>
+        <p:spPr>
+          <a:xfrm xmlns:a="http://schemas.openxmlformats.org/drawingml/2006/main">
+            <a:off x="971550" y="781050"/>
+            <a:ext cx="1257300" cy="76200"/>
+          </a:xfrm>
+          <a:prstGeom xmlns:a="http://schemas.openxmlformats.org/drawingml/2006/main" prst="rect">
+            <a:avLst/>
+          </a:prstGeom>
+          <a:solidFill xmlns:a="http://schemas.openxmlformats.org/drawingml/2006/main">
+            <a:srgbClr val="00A2EB"/>
+          </a:solidFill>
+          <a:ln xmlns:a="http://schemas.openxmlformats.org/drawingml/2006/main" w="9525">
+            <a:solidFill>
+              <a:srgbClr val="00A2EB"/>
+            </a:solidFill>
+            <a:prstDash val="solid"/>
+          </a:ln>
+        </p:spPr>
+      </p:sp>
+      <p:sp>
+        <p:nvSpPr>
+          <p:cNvPr id="2" name="">
+            <a:extLst xmlns:a="http://schemas.openxmlformats.org/drawingml/2006/main">
+              <a:ext uri="{FF2B5EF4-FFF2-40B4-BE49-F238E27FC236}">
+                <a16:creationId xmlns:a16="http://schemas.microsoft.com/office/drawing/2014/main" id="{64682EC5-19B2-4E56-87B3-7ADF11BC6291}"/>
+              </a:ext>
+            </a:extLst>
+          </p:cNvPr>
+          <p:cNvSpPr>
+            <a:spLocks xmlns:a="http://schemas.openxmlformats.org/drawingml/2006/main" noGrp="1"/>
+          </p:cNvSpPr>
+          <p:nvPr/>
+        </p:nvSpPr>
+        <p:spPr>
+          <a:xfrm xmlns:a="http://schemas.openxmlformats.org/drawingml/2006/main">
+            <a:off x="971550" y="1104900"/>
+            <a:ext cx="3048000" cy="304800"/>
+          </a:xfrm>
+          <a:prstGeom xmlns:a="http://schemas.openxmlformats.org/drawingml/2006/main" prst="rect">
+            <a:avLst/>
+          </a:prstGeom>
+          <a:noFill xmlns:a="http://schemas.openxmlformats.org/drawingml/2006/main"/>
+          <a:ln xmlns:a="http://schemas.openxmlformats.org/drawingml/2006/main" w="0">
+            <a:noFill/>
+            <a:prstDash val="solid"/>
+          </a:ln>
+        </p:spPr>
+        <p:txBody>
+          <a:bodyPr xmlns:a="http://schemas.openxmlformats.org/drawingml/2006/main" lIns="0" tIns="0" rIns="0" bIns="0" anchor="t"/>
+          <a:lstStyle xmlns:a="http://schemas.openxmlformats.org/drawingml/2006/main"/>
+          <a:p xmlns:a="http://schemas.openxmlformats.org/drawingml/2006/main">
+            <a:pPr>
+              <a:buNone/>
+              <a:defRPr sz="1500" b="1">
+                <a:solidFill>
+                  <a:srgbClr val="1F40CB"/>
+                </a:solidFill>
+                <a:latin typeface="Calibri"/>
+                <a:ea typeface="Calibri"/>
+                <a:cs typeface="Calibri"/>
+              </a:defRPr>
+            </a:pPr>
+            <a:r>
+              <a:rPr sz="1500" b="1">
+                <a:solidFill>
+                  <a:srgbClr val="1F40CB"/>
+                </a:solidFill>
+                <a:latin typeface="Calibri"/>
+                <a:ea typeface="Calibri"/>
+                <a:cs typeface="Calibri"/>
+              </a:rPr>
+              <a:t>FIRST FINANCE</a:t>
+            </a:r>
+          </a:p>
+        </p:txBody>
+      </p:sp>
+      <p:sp>
+        <p:nvSpPr>
+          <p:cNvPr id="3" name="">
+            <a:extLst xmlns:a="http://schemas.openxmlformats.org/drawingml/2006/main">
+              <a:ext uri="{FF2B5EF4-FFF2-40B4-BE49-F238E27FC236}">
+                <a16:creationId xmlns:a16="http://schemas.microsoft.com/office/drawing/2014/main" id="{728B1E4B-A80D-4DD8-B9C5-6F19ACF9BC87}"/>
+              </a:ext>
+            </a:extLst>
+          </p:cNvPr>
+          <p:cNvSpPr>
+            <a:spLocks xmlns:a="http://schemas.openxmlformats.org/drawingml/2006/main" noGrp="1"/>
+          </p:cNvSpPr>
+          <p:nvPr/>
+        </p:nvSpPr>
+        <p:spPr>
+          <a:xfrm xmlns:a="http://schemas.openxmlformats.org/drawingml/2006/main">
+            <a:off x="971550" y="2400300"/>
+            <a:ext cx="9334500" cy="1000125"/>
+          </a:xfrm>
+          <a:prstGeom xmlns:a="http://schemas.openxmlformats.org/drawingml/2006/main" prst="rect">
+            <a:avLst/>
+          </a:prstGeom>
+          <a:noFill xmlns:a="http://schemas.openxmlformats.org/drawingml/2006/main"/>
+          <a:ln xmlns:a="http://schemas.openxmlformats.org/drawingml/2006/main" w="0">
+            <a:noFill/>
+            <a:prstDash val="solid"/>
+          </a:ln>
+        </p:spPr>
+        <p:txBody>
+          <a:bodyPr xmlns:a="http://schemas.openxmlformats.org/drawingml/2006/main" lIns="0" tIns="0" rIns="0" bIns="0" anchor="t"/>
+          <a:lstStyle xmlns:a="http://schemas.openxmlformats.org/drawingml/2006/main"/>
+          <a:p xmlns:a="http://schemas.openxmlformats.org/drawingml/2006/main">
+            <a:pPr>
+              <a:buNone/>
+              <a:defRPr sz="4950" b="1">
+                <a:solidFill>
+                  <a:srgbClr val="051C2A"/>
+                </a:solidFill>
+                <a:latin typeface="Calibri"/>
+                <a:ea typeface="Calibri"/>
+                <a:cs typeface="Calibri"/>
+              </a:defRPr>
+            </a:pPr>
+            <a:r>
+              <a:rPr sz="4950" b="1">
+                <a:solidFill>
+                  <a:srgbClr val="051C2A"/>
+                </a:solidFill>
+                <a:latin typeface="Calibri"/>
+                <a:ea typeface="Calibri"/>
+                <a:cs typeface="Calibri"/>
+              </a:rPr>
+              <a:t>Quick quiz</a:t>
+            </a:r>
+          </a:p>
+        </p:txBody>
+      </p:sp>
+      <p:sp>
+        <p:nvSpPr>
+          <p:cNvPr id="4" name="">
+            <a:extLst xmlns:a="http://schemas.openxmlformats.org/drawingml/2006/main">
+              <a:ext uri="{FF2B5EF4-FFF2-40B4-BE49-F238E27FC236}">
+                <a16:creationId xmlns:a16="http://schemas.microsoft.com/office/drawing/2014/main" id="{EE83E63A-968D-469D-97F9-C2D3B82A7E4D}"/>
+              </a:ext>
+            </a:extLst>
+          </p:cNvPr>
+          <p:cNvSpPr>
+            <a:spLocks xmlns:a="http://schemas.openxmlformats.org/drawingml/2006/main" noGrp="1"/>
+          </p:cNvSpPr>
+          <p:nvPr/>
+        </p:nvSpPr>
+        <p:spPr>
+          <a:xfrm xmlns:a="http://schemas.openxmlformats.org/drawingml/2006/main">
+            <a:off x="971550" y="3638550"/>
+            <a:ext cx="10668000" cy="552450"/>
+          </a:xfrm>
+          <a:prstGeom xmlns:a="http://schemas.openxmlformats.org/drawingml/2006/main" prst="rect">
+            <a:avLst/>
+          </a:prstGeom>
+          <a:noFill xmlns:a="http://schemas.openxmlformats.org/drawingml/2006/main"/>
+          <a:ln xmlns:a="http://schemas.openxmlformats.org/drawingml/2006/main" w="0">
+            <a:noFill/>
+            <a:prstDash val="solid"/>
+          </a:ln>
+        </p:spPr>
+        <p:txBody>
+          <a:bodyPr xmlns:a="http://schemas.openxmlformats.org/drawingml/2006/main" lIns="0" tIns="0" rIns="0" bIns="0" anchor="t"/>
+          <a:lstStyle xmlns:a="http://schemas.openxmlformats.org/drawingml/2006/main"/>
+          <a:p xmlns:a="http://schemas.openxmlformats.org/drawingml/2006/main">
+            <a:pPr>
+              <a:buNone/>
+              <a:defRPr sz="2400">
+                <a:solidFill>
+                  <a:srgbClr val="373738"/>
+                </a:solidFill>
+                <a:latin typeface="Calibri"/>
+                <a:ea typeface="Calibri"/>
+                <a:cs typeface="Calibri"/>
+              </a:defRPr>
+            </a:pPr>
+            <a:r>
+              <a:rPr sz="2400">
+                <a:solidFill>
+                  <a:srgbClr val="373738"/>
+                </a:solidFill>
+                <a:latin typeface="Calibri"/>
+                <a:ea typeface="Calibri"/>
+                <a:cs typeface="Calibri"/>
+              </a:rPr>
+              <a:t>Choose one answer for each question.</a:t>
+            </a:r>
+          </a:p>
+        </p:txBody>
+      </p:sp>
+      <p:sp>
+        <p:nvSpPr>
+          <p:cNvPr id="5" name="">
+            <a:extLst xmlns:a="http://schemas.openxmlformats.org/drawingml/2006/main">
+              <a:ext uri="{FF2B5EF4-FFF2-40B4-BE49-F238E27FC236}">
+                <a16:creationId xmlns:a16="http://schemas.microsoft.com/office/drawing/2014/main" id="{001333EC-2C9C-4877-BD13-41F8B87FC676}"/>
+              </a:ext>
+            </a:extLst>
+          </p:cNvPr>
+          <p:cNvSpPr>
+            <a:spLocks xmlns:a="http://schemas.openxmlformats.org/drawingml/2006/main" noGrp="1"/>
+          </p:cNvSpPr>
+          <p:nvPr/>
+        </p:nvSpPr>
+        <p:spPr>
+          <a:xfrm xmlns:a="http://schemas.openxmlformats.org/drawingml/2006/main">
+            <a:off x="971550" y="6610350"/>
+            <a:ext cx="9525000" cy="323850"/>
+          </a:xfrm>
+          <a:prstGeom xmlns:a="http://schemas.openxmlformats.org/drawingml/2006/main" prst="rect">
+            <a:avLst/>
+          </a:prstGeom>
+          <a:noFill xmlns:a="http://schemas.openxmlformats.org/drawingml/2006/main"/>
+          <a:ln xmlns:a="http://schemas.openxmlformats.org/drawingml/2006/main" w="0">
+            <a:noFill/>
+            <a:prstDash val="solid"/>
+          </a:ln>
+        </p:spPr>
+        <p:txBody>
+          <a:bodyPr xmlns:a="http://schemas.openxmlformats.org/drawingml/2006/main" lIns="0" tIns="0" rIns="0" bIns="0" anchor="t"/>
+          <a:lstStyle xmlns:a="http://schemas.openxmlformats.org/drawingml/2006/main"/>
+          <a:p xmlns:a="http://schemas.openxmlformats.org/drawingml/2006/main">
+            <a:pPr>
+              <a:buNone/>
+              <a:defRPr sz="1425" b="1">
+                <a:solidFill>
+                  <a:srgbClr val="1F40CB"/>
+                </a:solidFill>
+                <a:latin typeface="Calibri"/>
+                <a:ea typeface="Calibri"/>
+                <a:cs typeface="Calibri"/>
+              </a:defRPr>
+            </a:pPr>
+            <a:r>
+              <a:rPr sz="1425" b="1">
+                <a:solidFill>
+                  <a:srgbClr val="1F40CB"/>
+                </a:solidFill>
+                <a:latin typeface="Calibri"/>
+                <a:ea typeface="Calibri"/>
+                <a:cs typeface="Calibri"/>
+              </a:rPr>
+              <a:t>LESSON 01  ·  3 QUESTIONS  ·  3 MINUTES</a:t>
+            </a:r>
+          </a:p>
+        </p:txBody>
+      </p:sp>
+      <p:sp>
+        <p:nvSpPr>
+          <p:cNvPr id="6" name="">
+            <a:extLst xmlns:a="http://schemas.openxmlformats.org/drawingml/2006/main">
+              <a:ext uri="{FF2B5EF4-FFF2-40B4-BE49-F238E27FC236}">
+                <a16:creationId xmlns:a16="http://schemas.microsoft.com/office/drawing/2014/main" id="{C1C3877F-F854-40AF-9C55-8A4B72F80AEA}"/>
+              </a:ext>
+            </a:extLst>
+          </p:cNvPr>
+          <p:cNvSpPr>
+            <a:spLocks xmlns:a="http://schemas.openxmlformats.org/drawingml/2006/main" noGrp="1"/>
+          </p:cNvSpPr>
+          <p:nvPr/>
+        </p:nvSpPr>
+        <p:spPr>
+          <a:xfrm xmlns:a="http://schemas.openxmlformats.org/drawingml/2006/main">
+            <a:off x="971550" y="7162800"/>
+            <a:ext cx="5143500" cy="361950"/>
+          </a:xfrm>
+          <a:prstGeom xmlns:a="http://schemas.openxmlformats.org/drawingml/2006/main" prst="rect">
+            <a:avLst/>
+          </a:prstGeom>
+          <a:noFill xmlns:a="http://schemas.openxmlformats.org/drawingml/2006/main"/>
+          <a:ln xmlns:a="http://schemas.openxmlformats.org/drawingml/2006/main" w="0">
+            <a:noFill/>
+            <a:prstDash val="solid"/>
+          </a:ln>
+        </p:spPr>
+        <p:txBody>
+          <a:bodyPr xmlns:a="http://schemas.openxmlformats.org/drawingml/2006/main" lIns="0" tIns="0" rIns="0" bIns="0" anchor="t"/>
+          <a:lstStyle xmlns:a="http://schemas.openxmlformats.org/drawingml/2006/main"/>
+          <a:p xmlns:a="http://schemas.openxmlformats.org/drawingml/2006/main">
+            <a:pPr>
+              <a:buNone/>
+              <a:defRPr sz="1800">
+                <a:solidFill>
+                  <a:srgbClr val="051C2A"/>
+                </a:solidFill>
+                <a:latin typeface="Calibri"/>
+                <a:ea typeface="Calibri"/>
+                <a:cs typeface="Calibri"/>
+              </a:defRPr>
+            </a:pPr>
+            <a:r>
+              <a:rPr sz="1800">
+                <a:solidFill>
+                  <a:srgbClr val="051C2A"/>
+                </a:solidFill>
+                <a:latin typeface="Calibri"/>
+                <a:ea typeface="Calibri"/>
+                <a:cs typeface="Calibri"/>
+              </a:rPr>
+              <a:t>First Finance - Arnaud Demes</a:t>
+            </a:r>
+          </a:p>
+        </p:txBody>
+      </p:sp>
+      <p:sp>
+        <p:nvSpPr>
+          <p:cNvPr id="8" name="quiz-question-1">
+            <a:extLst xmlns:a="http://schemas.openxmlformats.org/drawingml/2006/main">
+              <a:ext uri="{FF2B5EF4-FFF2-40B4-BE49-F238E27FC236}">
+                <a16:creationId xmlns:a16="http://schemas.microsoft.com/office/drawing/2014/main" id="{978B3153-5795-42DC-8F43-92017E252E01}"/>
+              </a:ext>
+            </a:extLst>
+          </p:cNvPr>
+          <p:cNvSpPr>
+            <a:spLocks xmlns:a="http://schemas.openxmlformats.org/drawingml/2006/main" noGrp="1"/>
+          </p:cNvSpPr>
+          <p:nvPr/>
+        </p:nvSpPr>
+        <p:spPr>
+          <a:xfrm xmlns:a="http://schemas.openxmlformats.org/drawingml/2006/main">
+            <a:off x="971550" y="4400550"/>
+            <a:ext cx="13296900" cy="285750"/>
+          </a:xfrm>
+          <a:prstGeom xmlns:a="http://schemas.openxmlformats.org/drawingml/2006/main" prst="rect">
+            <a:avLst/>
+          </a:prstGeom>
+          <a:noFill xmlns:a="http://schemas.openxmlformats.org/drawingml/2006/main"/>
+          <a:ln xmlns:a="http://schemas.openxmlformats.org/drawingml/2006/main" w="0">
+            <a:noFill/>
+            <a:prstDash val="solid"/>
+          </a:ln>
+        </p:spPr>
+        <p:txBody>
+          <a:bodyPr xmlns:a="http://schemas.openxmlformats.org/drawingml/2006/main"/>
+          <a:lstStyle xmlns:a="http://schemas.openxmlformats.org/drawingml/2006/main"/>
+          <a:p xmlns:a="http://schemas.openxmlformats.org/drawingml/2006/main">
+            <a:pPr>
+              <a:defRPr sz="1500" b="1">
+                <a:solidFill>
+                  <a:srgbClr val="001B2E"/>
+                </a:solidFill>
+              </a:defRPr>
+            </a:pPr>
+            <a:r>
+              <a:rPr sz="1500" b="1">
+                <a:solidFill>
+                  <a:srgbClr val="001B2E"/>
+                </a:solidFill>
+              </a:rPr>
+              <a:t>1. Which component hides provider-specific details?</a:t>
+            </a:r>
+          </a:p>
+        </p:txBody>
+      </p:sp>
+      <p:sp>
+        <p:nvSpPr>
+          <p:cNvPr id="9" name="quiz-options-1">
+            <a:extLst xmlns:a="http://schemas.openxmlformats.org/drawingml/2006/main">
+              <a:ext uri="{FF2B5EF4-FFF2-40B4-BE49-F238E27FC236}">
+                <a16:creationId xmlns:a16="http://schemas.microsoft.com/office/drawing/2014/main" id="{8C82FFED-AAD5-46E1-B8A1-DE96978D9347}"/>
+              </a:ext>
+            </a:extLst>
+          </p:cNvPr>
+          <p:cNvSpPr>
+            <a:spLocks xmlns:a="http://schemas.openxmlformats.org/drawingml/2006/main" noGrp="1"/>
+          </p:cNvSpPr>
+          <p:nvPr/>
+        </p:nvSpPr>
+        <p:spPr>
+          <a:xfrm xmlns:a="http://schemas.openxmlformats.org/drawingml/2006/main">
+            <a:off x="1257300" y="4705350"/>
+            <a:ext cx="13011150" cy="247650"/>
+          </a:xfrm>
+          <a:prstGeom xmlns:a="http://schemas.openxmlformats.org/drawingml/2006/main" prst="rect">
+            <a:avLst/>
+          </a:prstGeom>
+          <a:noFill xmlns:a="http://schemas.openxmlformats.org/drawingml/2006/main"/>
+          <a:ln xmlns:a="http://schemas.openxmlformats.org/drawingml/2006/main" w="0">
+            <a:noFill/>
+            <a:prstDash val="solid"/>
+          </a:ln>
+        </p:spPr>
+        <p:txBody>
+          <a:bodyPr xmlns:a="http://schemas.openxmlformats.org/drawingml/2006/main"/>
+          <a:lstStyle xmlns:a="http://schemas.openxmlformats.org/drawingml/2006/main"/>
+          <a:p xmlns:a="http://schemas.openxmlformats.org/drawingml/2006/main">
+            <a:pPr>
+              <a:defRPr sz="1200" b="0">
+                <a:solidFill>
+                  <a:srgbClr val="334155"/>
+                </a:solidFill>
+              </a:defRPr>
+            </a:pPr>
+            <a:r>
+              <a:rPr sz="1200" b="0">
+                <a:solidFill>
+                  <a:srgbClr val="334155"/>
+                </a:solidFill>
+              </a:rPr>
+              <a:t>A  Prompt     |     B  Model gateway     |     C  Vector database</a:t>
+            </a:r>
+          </a:p>
+        </p:txBody>
+      </p:sp>
+      <p:sp>
+        <p:nvSpPr>
+          <p:cNvPr id="10" name="quiz-question-2">
+            <a:extLst xmlns:a="http://schemas.openxmlformats.org/drawingml/2006/main">
+              <a:ext uri="{FF2B5EF4-FFF2-40B4-BE49-F238E27FC236}">
+                <a16:creationId xmlns:a16="http://schemas.microsoft.com/office/drawing/2014/main" id="{04A6BCD9-146A-498F-8ABA-21C97E34DDF2}"/>
+              </a:ext>
+            </a:extLst>
+          </p:cNvPr>
+          <p:cNvSpPr>
+            <a:spLocks xmlns:a="http://schemas.openxmlformats.org/drawingml/2006/main" noGrp="1"/>
+          </p:cNvSpPr>
+          <p:nvPr/>
+        </p:nvSpPr>
+        <p:spPr>
+          <a:xfrm xmlns:a="http://schemas.openxmlformats.org/drawingml/2006/main">
+            <a:off x="971550" y="5086350"/>
+            <a:ext cx="13296900" cy="285750"/>
+          </a:xfrm>
+          <a:prstGeom xmlns:a="http://schemas.openxmlformats.org/drawingml/2006/main" prst="rect">
+            <a:avLst/>
+          </a:prstGeom>
+          <a:noFill xmlns:a="http://schemas.openxmlformats.org/drawingml/2006/main"/>
+          <a:ln xmlns:a="http://schemas.openxmlformats.org/drawingml/2006/main" w="0">
+            <a:noFill/>
+            <a:prstDash val="solid"/>
+          </a:ln>
+        </p:spPr>
+        <p:txBody>
+          <a:bodyPr xmlns:a="http://schemas.openxmlformats.org/drawingml/2006/main"/>
+          <a:lstStyle xmlns:a="http://schemas.openxmlformats.org/drawingml/2006/main"/>
+          <a:p xmlns:a="http://schemas.openxmlformats.org/drawingml/2006/main">
+            <a:pPr>
+              <a:defRPr sz="1500" b="1">
+                <a:solidFill>
+                  <a:srgbClr val="001B2E"/>
+                </a:solidFill>
+              </a:defRPr>
+            </a:pPr>
+            <a:r>
+              <a:rPr sz="1500" b="1">
+                <a:solidFill>
+                  <a:srgbClr val="001B2E"/>
+                </a:solidFill>
+              </a:rPr>
+              <a:t>2. What does streaming mainly change?</a:t>
+            </a:r>
+          </a:p>
+        </p:txBody>
+      </p:sp>
+      <p:sp>
+        <p:nvSpPr>
+          <p:cNvPr id="11" name="quiz-options-2">
+            <a:extLst xmlns:a="http://schemas.openxmlformats.org/drawingml/2006/main">
+              <a:ext uri="{FF2B5EF4-FFF2-40B4-BE49-F238E27FC236}">
+                <a16:creationId xmlns:a16="http://schemas.microsoft.com/office/drawing/2014/main" id="{3FE8F5DC-6EBC-49A4-87F8-1BB09EAC1C79}"/>
+              </a:ext>
+            </a:extLst>
+          </p:cNvPr>
+          <p:cNvSpPr>
+            <a:spLocks xmlns:a="http://schemas.openxmlformats.org/drawingml/2006/main" noGrp="1"/>
+          </p:cNvSpPr>
+          <p:nvPr/>
+        </p:nvSpPr>
+        <p:spPr>
+          <a:xfrm xmlns:a="http://schemas.openxmlformats.org/drawingml/2006/main">
+            <a:off x="1257300" y="5391150"/>
+            <a:ext cx="13011150" cy="247650"/>
+          </a:xfrm>
+          <a:prstGeom xmlns:a="http://schemas.openxmlformats.org/drawingml/2006/main" prst="rect">
+            <a:avLst/>
+          </a:prstGeom>
+          <a:noFill xmlns:a="http://schemas.openxmlformats.org/drawingml/2006/main"/>
+          <a:ln xmlns:a="http://schemas.openxmlformats.org/drawingml/2006/main" w="0">
+            <a:noFill/>
+            <a:prstDash val="solid"/>
+          </a:ln>
+        </p:spPr>
+        <p:txBody>
+          <a:bodyPr xmlns:a="http://schemas.openxmlformats.org/drawingml/2006/main"/>
+          <a:lstStyle xmlns:a="http://schemas.openxmlformats.org/drawingml/2006/main"/>
+          <a:p xmlns:a="http://schemas.openxmlformats.org/drawingml/2006/main">
+            <a:pPr>
+              <a:defRPr sz="1200" b="0">
+                <a:solidFill>
+                  <a:srgbClr val="334155"/>
+                </a:solidFill>
+              </a:defRPr>
+            </a:pPr>
+            <a:r>
+              <a:rPr sz="1200" b="0">
+                <a:solidFill>
+                  <a:srgbClr val="334155"/>
+                </a:solidFill>
+              </a:rPr>
+              <a:t>A  Delivery     |     B  Grounding     |     C  Factual quality</a:t>
+            </a:r>
+          </a:p>
+        </p:txBody>
+      </p:sp>
+      <p:sp>
+        <p:nvSpPr>
+          <p:cNvPr id="12" name="quiz-question-3">
+            <a:extLst xmlns:a="http://schemas.openxmlformats.org/drawingml/2006/main">
+              <a:ext uri="{FF2B5EF4-FFF2-40B4-BE49-F238E27FC236}">
+                <a16:creationId xmlns:a16="http://schemas.microsoft.com/office/drawing/2014/main" id="{01A332D2-FD44-44AA-8DB4-875ACE1E6B0C}"/>
+              </a:ext>
+            </a:extLst>
+          </p:cNvPr>
+          <p:cNvSpPr>
+            <a:spLocks xmlns:a="http://schemas.openxmlformats.org/drawingml/2006/main" noGrp="1"/>
+          </p:cNvSpPr>
+          <p:nvPr/>
+        </p:nvSpPr>
+        <p:spPr>
+          <a:xfrm xmlns:a="http://schemas.openxmlformats.org/drawingml/2006/main">
+            <a:off x="971550" y="5772150"/>
+            <a:ext cx="13296900" cy="285750"/>
+          </a:xfrm>
+          <a:prstGeom xmlns:a="http://schemas.openxmlformats.org/drawingml/2006/main" prst="rect">
+            <a:avLst/>
+          </a:prstGeom>
+          <a:noFill xmlns:a="http://schemas.openxmlformats.org/drawingml/2006/main"/>
+          <a:ln xmlns:a="http://schemas.openxmlformats.org/drawingml/2006/main" w="0">
+            <a:noFill/>
+            <a:prstDash val="solid"/>
+          </a:ln>
+        </p:spPr>
+        <p:txBody>
+          <a:bodyPr xmlns:a="http://schemas.openxmlformats.org/drawingml/2006/main"/>
+          <a:lstStyle xmlns:a="http://schemas.openxmlformats.org/drawingml/2006/main"/>
+          <a:p xmlns:a="http://schemas.openxmlformats.org/drawingml/2006/main">
+            <a:pPr>
+              <a:defRPr sz="1500" b="1">
+                <a:solidFill>
+                  <a:srgbClr val="001B2E"/>
+                </a:solidFill>
+              </a:defRPr>
+            </a:pPr>
+            <a:r>
+              <a:rPr sz="1500" b="1">
+                <a:solidFill>
+                  <a:srgbClr val="001B2E"/>
+                </a:solidFill>
+              </a:rPr>
+              <a:t>3. What should the gateway record when token metadata is missing?</a:t>
+            </a:r>
+          </a:p>
+        </p:txBody>
+      </p:sp>
+      <p:sp>
+        <p:nvSpPr>
+          <p:cNvPr id="13" name="quiz-options-3">
+            <a:extLst xmlns:a="http://schemas.openxmlformats.org/drawingml/2006/main">
+              <a:ext uri="{FF2B5EF4-FFF2-40B4-BE49-F238E27FC236}">
+                <a16:creationId xmlns:a16="http://schemas.microsoft.com/office/drawing/2014/main" id="{C270705C-CBF2-49FA-A949-07B07719CAFA}"/>
+              </a:ext>
+            </a:extLst>
+          </p:cNvPr>
+          <p:cNvSpPr>
+            <a:spLocks xmlns:a="http://schemas.openxmlformats.org/drawingml/2006/main" noGrp="1"/>
+          </p:cNvSpPr>
+          <p:nvPr/>
+        </p:nvSpPr>
+        <p:spPr>
+          <a:xfrm xmlns:a="http://schemas.openxmlformats.org/drawingml/2006/main">
+            <a:off x="1257300" y="6076950"/>
+            <a:ext cx="13011150" cy="247650"/>
+          </a:xfrm>
+          <a:prstGeom xmlns:a="http://schemas.openxmlformats.org/drawingml/2006/main" prst="rect">
+            <a:avLst/>
+          </a:prstGeom>
+          <a:noFill xmlns:a="http://schemas.openxmlformats.org/drawingml/2006/main"/>
+          <a:ln xmlns:a="http://schemas.openxmlformats.org/drawingml/2006/main" w="0">
+            <a:noFill/>
+            <a:prstDash val="solid"/>
+          </a:ln>
+        </p:spPr>
+        <p:txBody>
+          <a:bodyPr xmlns:a="http://schemas.openxmlformats.org/drawingml/2006/main"/>
+          <a:lstStyle xmlns:a="http://schemas.openxmlformats.org/drawingml/2006/main"/>
+          <a:p xmlns:a="http://schemas.openxmlformats.org/drawingml/2006/main">
+            <a:pPr>
+              <a:defRPr sz="1200" b="0">
+                <a:solidFill>
+                  <a:srgbClr val="334155"/>
+                </a:solidFill>
+              </a:defRPr>
+            </a:pPr>
+            <a:r>
+              <a:rPr sz="1200" b="0">
+                <a:solidFill>
+                  <a:srgbClr val="334155"/>
+                </a:solidFill>
+              </a:rPr>
+              <a:t>A  Zero     |     B  None     |     C  An estimate</a:t>
+            </a:r>
+          </a:p>
+        </p:txBody>
+      </p:sp>
+    </p:spTree>
+    <p:extLst>
+      <p:ext uri="{BB962C8B-B14F-4D97-AF65-F5344CB8AC3E}">
+        <p14:creationId xmlns:p14="http://schemas.microsoft.com/office/powerpoint/2010/main" val="767502565"/>
+      </p:ext>
+    </p:extLst>
+  </p:cSld>
+</p:sld>
+</file>
+
+<file path=ppt/slides/slide9.xml><?xml version="1.0" encoding="utf-8"?>
+<p:sld xmlns:p="http://schemas.openxmlformats.org/presentationml/2006/main">
+  <p:cSld>
+    <p:bg>
+      <p:bgPr>
+        <a:solidFill xmlns:a="http://schemas.openxmlformats.org/drawingml/2006/main">
+          <a:srgbClr val="F5F5F5"/>
+        </a:solidFill>
+      </p:bgPr>
+    </p:bg>
+    <p:spTree>
+      <p:nvGrpSpPr>
+        <p:cNvPr id="1" name=""/>
+        <p:cNvGrpSpPr/>
+        <p:nvPr/>
+      </p:nvGrpSpPr>
+      <p:grpSpPr>
+        <a:xfrm xmlns:a="http://schemas.openxmlformats.org/drawingml/2006/main"/>
+      </p:grpSpPr>
+      <p:sp>
+        <p:nvSpPr>
+          <p:cNvPr id="7" name="">
+            <a:extLst xmlns:a="http://schemas.openxmlformats.org/drawingml/2006/main">
+              <a:ext uri="{FF2B5EF4-FFF2-40B4-BE49-F238E27FC236}">
+                <a16:creationId xmlns:a16="http://schemas.microsoft.com/office/drawing/2014/main" id="{1291AC7A-C390-4918-960F-B031B7C93A63}"/>
+              </a:ext>
+            </a:extLst>
+          </p:cNvPr>
+          <p:cNvSpPr>
+            <a:spLocks xmlns:a="http://schemas.openxmlformats.org/drawingml/2006/main" noGrp="1"/>
+          </p:cNvSpPr>
+          <p:nvPr/>
+        </p:nvSpPr>
+        <p:spPr>
+          <a:xfrm xmlns:a="http://schemas.openxmlformats.org/drawingml/2006/main">
+            <a:off x="971550" y="781050"/>
+            <a:ext cx="1257300" cy="76200"/>
+          </a:xfrm>
+          <a:prstGeom xmlns:a="http://schemas.openxmlformats.org/drawingml/2006/main" prst="rect">
+            <a:avLst/>
+          </a:prstGeom>
+          <a:solidFill xmlns:a="http://schemas.openxmlformats.org/drawingml/2006/main">
+            <a:srgbClr val="00A2EB"/>
+          </a:solidFill>
+          <a:ln xmlns:a="http://schemas.openxmlformats.org/drawingml/2006/main" w="9525">
+            <a:solidFill>
+              <a:srgbClr val="00A2EB"/>
+            </a:solidFill>
+            <a:prstDash val="solid"/>
+          </a:ln>
+        </p:spPr>
+      </p:sp>
+      <p:sp>
+        <p:nvSpPr>
+          <p:cNvPr id="2" name="">
+            <a:extLst xmlns:a="http://schemas.openxmlformats.org/drawingml/2006/main">
+              <a:ext uri="{FF2B5EF4-FFF2-40B4-BE49-F238E27FC236}">
+                <a16:creationId xmlns:a16="http://schemas.microsoft.com/office/drawing/2014/main" id="{64682EC5-19B2-4E56-87B3-7ADF11BC6291}"/>
+              </a:ext>
+            </a:extLst>
+          </p:cNvPr>
+          <p:cNvSpPr>
+            <a:spLocks xmlns:a="http://schemas.openxmlformats.org/drawingml/2006/main" noGrp="1"/>
+          </p:cNvSpPr>
+          <p:nvPr/>
+        </p:nvSpPr>
+        <p:spPr>
+          <a:xfrm xmlns:a="http://schemas.openxmlformats.org/drawingml/2006/main">
+            <a:off x="971550" y="1104900"/>
+            <a:ext cx="3048000" cy="304800"/>
+          </a:xfrm>
+          <a:prstGeom xmlns:a="http://schemas.openxmlformats.org/drawingml/2006/main" prst="rect">
+            <a:avLst/>
+          </a:prstGeom>
+          <a:noFill xmlns:a="http://schemas.openxmlformats.org/drawingml/2006/main"/>
+          <a:ln xmlns:a="http://schemas.openxmlformats.org/drawingml/2006/main" w="0">
+            <a:noFill/>
+            <a:prstDash val="solid"/>
+          </a:ln>
+        </p:spPr>
+        <p:txBody>
+          <a:bodyPr xmlns:a="http://schemas.openxmlformats.org/drawingml/2006/main" lIns="0" tIns="0" rIns="0" bIns="0" anchor="t"/>
+          <a:lstStyle xmlns:a="http://schemas.openxmlformats.org/drawingml/2006/main"/>
+          <a:p xmlns:a="http://schemas.openxmlformats.org/drawingml/2006/main">
+            <a:pPr>
+              <a:buNone/>
+              <a:defRPr sz="1500" b="1">
+                <a:solidFill>
+                  <a:srgbClr val="1F40CB"/>
+                </a:solidFill>
+                <a:latin typeface="Calibri"/>
+                <a:ea typeface="Calibri"/>
+                <a:cs typeface="Calibri"/>
+              </a:defRPr>
+            </a:pPr>
+            <a:r>
+              <a:rPr sz="1500" b="1">
+                <a:solidFill>
+                  <a:srgbClr val="1F40CB"/>
+                </a:solidFill>
+                <a:latin typeface="Calibri"/>
+                <a:ea typeface="Calibri"/>
+                <a:cs typeface="Calibri"/>
+              </a:rPr>
+              <a:t>FIRST FINANCE</a:t>
+            </a:r>
+          </a:p>
+        </p:txBody>
+      </p:sp>
+      <p:sp>
+        <p:nvSpPr>
+          <p:cNvPr id="3" name="">
+            <a:extLst xmlns:a="http://schemas.openxmlformats.org/drawingml/2006/main">
+              <a:ext uri="{FF2B5EF4-FFF2-40B4-BE49-F238E27FC236}">
+                <a16:creationId xmlns:a16="http://schemas.microsoft.com/office/drawing/2014/main" id="{728B1E4B-A80D-4DD8-B9C5-6F19ACF9BC87}"/>
+              </a:ext>
+            </a:extLst>
+          </p:cNvPr>
+          <p:cNvSpPr>
+            <a:spLocks xmlns:a="http://schemas.openxmlformats.org/drawingml/2006/main" noGrp="1"/>
+          </p:cNvSpPr>
+          <p:nvPr/>
+        </p:nvSpPr>
+        <p:spPr>
+          <a:xfrm xmlns:a="http://schemas.openxmlformats.org/drawingml/2006/main">
+            <a:off x="971550" y="2400300"/>
+            <a:ext cx="9334500" cy="1000125"/>
+          </a:xfrm>
+          <a:prstGeom xmlns:a="http://schemas.openxmlformats.org/drawingml/2006/main" prst="rect">
+            <a:avLst/>
+          </a:prstGeom>
+          <a:noFill xmlns:a="http://schemas.openxmlformats.org/drawingml/2006/main"/>
+          <a:ln xmlns:a="http://schemas.openxmlformats.org/drawingml/2006/main" w="0">
+            <a:noFill/>
+            <a:prstDash val="solid"/>
+          </a:ln>
+        </p:spPr>
+        <p:txBody>
+          <a:bodyPr xmlns:a="http://schemas.openxmlformats.org/drawingml/2006/main" lIns="0" tIns="0" rIns="0" bIns="0" anchor="t"/>
+          <a:lstStyle xmlns:a="http://schemas.openxmlformats.org/drawingml/2006/main"/>
+          <a:p xmlns:a="http://schemas.openxmlformats.org/drawingml/2006/main">
+            <a:pPr>
+              <a:buNone/>
+              <a:defRPr sz="4950" b="1">
+                <a:solidFill>
+                  <a:srgbClr val="051C2A"/>
+                </a:solidFill>
+                <a:latin typeface="Calibri"/>
+                <a:ea typeface="Calibri"/>
+                <a:cs typeface="Calibri"/>
+              </a:defRPr>
+            </a:pPr>
+            <a:r>
+              <a:rPr sz="4950" b="1">
+                <a:solidFill>
+                  <a:srgbClr val="051C2A"/>
+                </a:solidFill>
+                <a:latin typeface="Calibri"/>
+                <a:ea typeface="Calibri"/>
+                <a:cs typeface="Calibri"/>
+              </a:rPr>
+              <a:t>Answers</a:t>
+            </a:r>
+          </a:p>
+        </p:txBody>
+      </p:sp>
+      <p:sp>
+        <p:nvSpPr>
+          <p:cNvPr id="4" name="">
+            <a:extLst xmlns:a="http://schemas.openxmlformats.org/drawingml/2006/main">
+              <a:ext uri="{FF2B5EF4-FFF2-40B4-BE49-F238E27FC236}">
+                <a16:creationId xmlns:a16="http://schemas.microsoft.com/office/drawing/2014/main" id="{EE83E63A-968D-469D-97F9-C2D3B82A7E4D}"/>
+              </a:ext>
+            </a:extLst>
+          </p:cNvPr>
+          <p:cNvSpPr>
+            <a:spLocks xmlns:a="http://schemas.openxmlformats.org/drawingml/2006/main" noGrp="1"/>
+          </p:cNvSpPr>
+          <p:nvPr/>
+        </p:nvSpPr>
+        <p:spPr>
+          <a:xfrm xmlns:a="http://schemas.openxmlformats.org/drawingml/2006/main">
+            <a:off x="971550" y="3638550"/>
+            <a:ext cx="10668000" cy="552450"/>
+          </a:xfrm>
+          <a:prstGeom xmlns:a="http://schemas.openxmlformats.org/drawingml/2006/main" prst="rect">
+            <a:avLst/>
+          </a:prstGeom>
+          <a:noFill xmlns:a="http://schemas.openxmlformats.org/drawingml/2006/main"/>
+          <a:ln xmlns:a="http://schemas.openxmlformats.org/drawingml/2006/main" w="0">
+            <a:noFill/>
+            <a:prstDash val="solid"/>
+          </a:ln>
+        </p:spPr>
+        <p:txBody>
+          <a:bodyPr xmlns:a="http://schemas.openxmlformats.org/drawingml/2006/main" lIns="0" tIns="0" rIns="0" bIns="0" anchor="t"/>
+          <a:lstStyle xmlns:a="http://schemas.openxmlformats.org/drawingml/2006/main"/>
+          <a:p xmlns:a="http://schemas.openxmlformats.org/drawingml/2006/main">
+            <a:pPr>
+              <a:buNone/>
+              <a:defRPr sz="2400">
+                <a:solidFill>
+                  <a:srgbClr val="373738"/>
+                </a:solidFill>
+                <a:latin typeface="Calibri"/>
+                <a:ea typeface="Calibri"/>
+                <a:cs typeface="Calibri"/>
+              </a:defRPr>
+            </a:pPr>
+            <a:r>
+              <a:rPr sz="2400">
+                <a:solidFill>
+                  <a:srgbClr val="373738"/>
+                </a:solidFill>
+                <a:latin typeface="Calibri"/>
+                <a:ea typeface="Calibri"/>
+                <a:cs typeface="Calibri"/>
+              </a:rPr>
+              <a:t>Check the idea, not only the letter.</a:t>
+            </a:r>
+          </a:p>
+        </p:txBody>
+      </p:sp>
+      <p:sp>
+        <p:nvSpPr>
+          <p:cNvPr id="5" name="">
+            <a:extLst xmlns:a="http://schemas.openxmlformats.org/drawingml/2006/main">
+              <a:ext uri="{FF2B5EF4-FFF2-40B4-BE49-F238E27FC236}">
+                <a16:creationId xmlns:a16="http://schemas.microsoft.com/office/drawing/2014/main" id="{001333EC-2C9C-4877-BD13-41F8B87FC676}"/>
+              </a:ext>
+            </a:extLst>
+          </p:cNvPr>
+          <p:cNvSpPr>
+            <a:spLocks xmlns:a="http://schemas.openxmlformats.org/drawingml/2006/main" noGrp="1"/>
+          </p:cNvSpPr>
+          <p:nvPr/>
+        </p:nvSpPr>
+        <p:spPr>
+          <a:xfrm xmlns:a="http://schemas.openxmlformats.org/drawingml/2006/main">
+            <a:off x="971550" y="6610350"/>
+            <a:ext cx="9525000" cy="323850"/>
+          </a:xfrm>
+          <a:prstGeom xmlns:a="http://schemas.openxmlformats.org/drawingml/2006/main" prst="rect">
+            <a:avLst/>
+          </a:prstGeom>
+          <a:noFill xmlns:a="http://schemas.openxmlformats.org/drawingml/2006/main"/>
+          <a:ln xmlns:a="http://schemas.openxmlformats.org/drawingml/2006/main" w="0">
+            <a:noFill/>
+            <a:prstDash val="solid"/>
+          </a:ln>
+        </p:spPr>
+        <p:txBody>
+          <a:bodyPr xmlns:a="http://schemas.openxmlformats.org/drawingml/2006/main" lIns="0" tIns="0" rIns="0" bIns="0" anchor="t"/>
+          <a:lstStyle xmlns:a="http://schemas.openxmlformats.org/drawingml/2006/main"/>
+          <a:p xmlns:a="http://schemas.openxmlformats.org/drawingml/2006/main">
+            <a:pPr>
+              <a:buNone/>
+              <a:defRPr sz="1425" b="1">
+                <a:solidFill>
+                  <a:srgbClr val="1F40CB"/>
+                </a:solidFill>
+                <a:latin typeface="Calibri"/>
+                <a:ea typeface="Calibri"/>
+                <a:cs typeface="Calibri"/>
+              </a:defRPr>
+            </a:pPr>
+            <a:r>
+              <a:rPr sz="1425" b="1">
+                <a:solidFill>
+                  <a:srgbClr val="1F40CB"/>
+                </a:solidFill>
+                <a:latin typeface="Calibri"/>
+                <a:ea typeface="Calibri"/>
+                <a:cs typeface="Calibri"/>
+              </a:rPr>
+              <a:t>LESSON 01  ·  CORRECTION</a:t>
+            </a:r>
+          </a:p>
+        </p:txBody>
+      </p:sp>
+      <p:sp>
+        <p:nvSpPr>
+          <p:cNvPr id="6" name="">
+            <a:extLst xmlns:a="http://schemas.openxmlformats.org/drawingml/2006/main">
+              <a:ext uri="{FF2B5EF4-FFF2-40B4-BE49-F238E27FC236}">
+                <a16:creationId xmlns:a16="http://schemas.microsoft.com/office/drawing/2014/main" id="{C1C3877F-F854-40AF-9C55-8A4B72F80AEA}"/>
+              </a:ext>
+            </a:extLst>
+          </p:cNvPr>
+          <p:cNvSpPr>
+            <a:spLocks xmlns:a="http://schemas.openxmlformats.org/drawingml/2006/main" noGrp="1"/>
+          </p:cNvSpPr>
+          <p:nvPr/>
+        </p:nvSpPr>
+        <p:spPr>
+          <a:xfrm xmlns:a="http://schemas.openxmlformats.org/drawingml/2006/main">
+            <a:off x="971550" y="7162800"/>
+            <a:ext cx="5143500" cy="361950"/>
+          </a:xfrm>
+          <a:prstGeom xmlns:a="http://schemas.openxmlformats.org/drawingml/2006/main" prst="rect">
+            <a:avLst/>
+          </a:prstGeom>
+          <a:noFill xmlns:a="http://schemas.openxmlformats.org/drawingml/2006/main"/>
+          <a:ln xmlns:a="http://schemas.openxmlformats.org/drawingml/2006/main" w="0">
+            <a:noFill/>
+            <a:prstDash val="solid"/>
+          </a:ln>
+        </p:spPr>
+        <p:txBody>
+          <a:bodyPr xmlns:a="http://schemas.openxmlformats.org/drawingml/2006/main" lIns="0" tIns="0" rIns="0" bIns="0" anchor="t"/>
+          <a:lstStyle xmlns:a="http://schemas.openxmlformats.org/drawingml/2006/main"/>
+          <a:p xmlns:a="http://schemas.openxmlformats.org/drawingml/2006/main">
+            <a:pPr>
+              <a:buNone/>
+              <a:defRPr sz="1800">
+                <a:solidFill>
+                  <a:srgbClr val="051C2A"/>
+                </a:solidFill>
+                <a:latin typeface="Calibri"/>
+                <a:ea typeface="Calibri"/>
+                <a:cs typeface="Calibri"/>
+              </a:defRPr>
+            </a:pPr>
+            <a:r>
+              <a:rPr sz="1800">
+                <a:solidFill>
+                  <a:srgbClr val="051C2A"/>
+                </a:solidFill>
+                <a:latin typeface="Calibri"/>
+                <a:ea typeface="Calibri"/>
+                <a:cs typeface="Calibri"/>
+              </a:rPr>
+              <a:t>First Finance - Arnaud Demes</a:t>
+            </a:r>
+          </a:p>
+        </p:txBody>
+      </p:sp>
+      <p:sp>
+        <p:nvSpPr>
+          <p:cNvPr id="8" name="quiz-answer-1">
+            <a:extLst xmlns:a="http://schemas.openxmlformats.org/drawingml/2006/main">
+              <a:ext uri="{FF2B5EF4-FFF2-40B4-BE49-F238E27FC236}">
+                <a16:creationId xmlns:a16="http://schemas.microsoft.com/office/drawing/2014/main" id="{3204DA93-A6A4-440A-8B66-1D43E0675402}"/>
+              </a:ext>
+            </a:extLst>
+          </p:cNvPr>
+          <p:cNvSpPr>
+            <a:spLocks xmlns:a="http://schemas.openxmlformats.org/drawingml/2006/main" noGrp="1"/>
+          </p:cNvSpPr>
+          <p:nvPr/>
+        </p:nvSpPr>
+        <p:spPr>
+          <a:xfrm xmlns:a="http://schemas.openxmlformats.org/drawingml/2006/main">
+            <a:off x="971550" y="4400550"/>
+            <a:ext cx="13296900" cy="285750"/>
+          </a:xfrm>
+          <a:prstGeom xmlns:a="http://schemas.openxmlformats.org/drawingml/2006/main" prst="rect">
+            <a:avLst/>
+          </a:prstGeom>
+          <a:noFill xmlns:a="http://schemas.openxmlformats.org/drawingml/2006/main"/>
+          <a:ln xmlns:a="http://schemas.openxmlformats.org/drawingml/2006/main" w="0">
+            <a:noFill/>
+            <a:prstDash val="solid"/>
+          </a:ln>
+        </p:spPr>
+        <p:txBody>
+          <a:bodyPr xmlns:a="http://schemas.openxmlformats.org/drawingml/2006/main"/>
+          <a:lstStyle xmlns:a="http://schemas.openxmlformats.org/drawingml/2006/main"/>
+          <a:p xmlns:a="http://schemas.openxmlformats.org/drawingml/2006/main">
+            <a:pPr>
+              <a:defRPr sz="1500" b="1">
+                <a:solidFill>
+                  <a:srgbClr val="1F40CB"/>
+                </a:solidFill>
+              </a:defRPr>
+            </a:pPr>
+            <a:r>
+              <a:rPr sz="1500" b="1">
+                <a:solidFill>
+                  <a:srgbClr val="1F40CB"/>
+                </a:solidFill>
+              </a:rPr>
+              <a:t>1. B. Model gateway</a:t>
+            </a:r>
+          </a:p>
+        </p:txBody>
+      </p:sp>
+      <p:sp>
+        <p:nvSpPr>
+          <p:cNvPr id="9" name="quiz-explanation-1">
+            <a:extLst xmlns:a="http://schemas.openxmlformats.org/drawingml/2006/main">
+              <a:ext uri="{FF2B5EF4-FFF2-40B4-BE49-F238E27FC236}">
+                <a16:creationId xmlns:a16="http://schemas.microsoft.com/office/drawing/2014/main" id="{1AE726AF-4E9A-4C19-BF3B-6A6049C8590C}"/>
+              </a:ext>
+            </a:extLst>
+          </p:cNvPr>
+          <p:cNvSpPr>
+            <a:spLocks xmlns:a="http://schemas.openxmlformats.org/drawingml/2006/main" noGrp="1"/>
+          </p:cNvSpPr>
+          <p:nvPr/>
+        </p:nvSpPr>
+        <p:spPr>
+          <a:xfrm xmlns:a="http://schemas.openxmlformats.org/drawingml/2006/main">
+            <a:off x="1257300" y="4705350"/>
+            <a:ext cx="13011150" cy="247650"/>
+          </a:xfrm>
+          <a:prstGeom xmlns:a="http://schemas.openxmlformats.org/drawingml/2006/main" prst="rect">
+            <a:avLst/>
+          </a:prstGeom>
+          <a:noFill xmlns:a="http://schemas.openxmlformats.org/drawingml/2006/main"/>
+          <a:ln xmlns:a="http://schemas.openxmlformats.org/drawingml/2006/main" w="0">
+            <a:noFill/>
+            <a:prstDash val="solid"/>
+          </a:ln>
+        </p:spPr>
+        <p:txBody>
+          <a:bodyPr xmlns:a="http://schemas.openxmlformats.org/drawingml/2006/main"/>
+          <a:lstStyle xmlns:a="http://schemas.openxmlformats.org/drawingml/2006/main"/>
+          <a:p xmlns:a="http://schemas.openxmlformats.org/drawingml/2006/main">
+            <a:pPr>
+              <a:defRPr sz="1200" b="0">
+                <a:solidFill>
+                  <a:srgbClr val="334155"/>
+                </a:solidFill>
+              </a:defRPr>
+            </a:pPr>
+            <a:r>
+              <a:rPr sz="1200" b="0">
+                <a:solidFill>
+                  <a:srgbClr val="334155"/>
+                </a:solidFill>
+              </a:rPr>
+              <a:t>It keeps provider changes behind one stable application interface.</a:t>
+            </a:r>
+          </a:p>
+        </p:txBody>
+      </p:sp>
+      <p:sp>
+        <p:nvSpPr>
+          <p:cNvPr id="10" name="quiz-answer-2">
+            <a:extLst xmlns:a="http://schemas.openxmlformats.org/drawingml/2006/main">
+              <a:ext uri="{FF2B5EF4-FFF2-40B4-BE49-F238E27FC236}">
+                <a16:creationId xmlns:a16="http://schemas.microsoft.com/office/drawing/2014/main" id="{5CF84115-5676-4FDB-8457-A8680B20AE16}"/>
+              </a:ext>
+            </a:extLst>
+          </p:cNvPr>
+          <p:cNvSpPr>
+            <a:spLocks xmlns:a="http://schemas.openxmlformats.org/drawingml/2006/main" noGrp="1"/>
+          </p:cNvSpPr>
+          <p:nvPr/>
+        </p:nvSpPr>
+        <p:spPr>
+          <a:xfrm xmlns:a="http://schemas.openxmlformats.org/drawingml/2006/main">
+            <a:off x="971550" y="5086350"/>
+            <a:ext cx="13296900" cy="285750"/>
+          </a:xfrm>
+          <a:prstGeom xmlns:a="http://schemas.openxmlformats.org/drawingml/2006/main" prst="rect">
+            <a:avLst/>
+          </a:prstGeom>
+          <a:noFill xmlns:a="http://schemas.openxmlformats.org/drawingml/2006/main"/>
+          <a:ln xmlns:a="http://schemas.openxmlformats.org/drawingml/2006/main" w="0">
+            <a:noFill/>
+            <a:prstDash val="solid"/>
+          </a:ln>
+        </p:spPr>
+        <p:txBody>
+          <a:bodyPr xmlns:a="http://schemas.openxmlformats.org/drawingml/2006/main"/>
+          <a:lstStyle xmlns:a="http://schemas.openxmlformats.org/drawingml/2006/main"/>
+          <a:p xmlns:a="http://schemas.openxmlformats.org/drawingml/2006/main">
+            <a:pPr>
+              <a:defRPr sz="1500" b="1">
+                <a:solidFill>
+                  <a:srgbClr val="1F40CB"/>
+                </a:solidFill>
+              </a:defRPr>
+            </a:pPr>
+            <a:r>
+              <a:rPr sz="1500" b="1">
+                <a:solidFill>
+                  <a:srgbClr val="1F40CB"/>
+                </a:solidFill>
+              </a:rPr>
+              <a:t>2. A. Delivery</a:t>
+            </a:r>
+          </a:p>
+        </p:txBody>
+      </p:sp>
+      <p:sp>
+        <p:nvSpPr>
+          <p:cNvPr id="11" name="quiz-explanation-2">
+            <a:extLst xmlns:a="http://schemas.openxmlformats.org/drawingml/2006/main">
+              <a:ext uri="{FF2B5EF4-FFF2-40B4-BE49-F238E27FC236}">
+                <a16:creationId xmlns:a16="http://schemas.microsoft.com/office/drawing/2014/main" id="{C0A11BD1-E2FB-4B9E-9E45-B60ED36E0EFD}"/>
+              </a:ext>
+            </a:extLst>
+          </p:cNvPr>
+          <p:cNvSpPr>
+            <a:spLocks xmlns:a="http://schemas.openxmlformats.org/drawingml/2006/main" noGrp="1"/>
+          </p:cNvSpPr>
+          <p:nvPr/>
+        </p:nvSpPr>
+        <p:spPr>
+          <a:xfrm xmlns:a="http://schemas.openxmlformats.org/drawingml/2006/main">
+            <a:off x="1257300" y="5391150"/>
+            <a:ext cx="13011150" cy="247650"/>
+          </a:xfrm>
+          <a:prstGeom xmlns:a="http://schemas.openxmlformats.org/drawingml/2006/main" prst="rect">
+            <a:avLst/>
+          </a:prstGeom>
+          <a:noFill xmlns:a="http://schemas.openxmlformats.org/drawingml/2006/main"/>
+          <a:ln xmlns:a="http://schemas.openxmlformats.org/drawingml/2006/main" w="0">
+            <a:noFill/>
+            <a:prstDash val="solid"/>
+          </a:ln>
+        </p:spPr>
+        <p:txBody>
+          <a:bodyPr xmlns:a="http://schemas.openxmlformats.org/drawingml/2006/main"/>
+          <a:lstStyle xmlns:a="http://schemas.openxmlformats.org/drawingml/2006/main"/>
+          <a:p xmlns:a="http://schemas.openxmlformats.org/drawingml/2006/main">
+            <a:pPr>
+              <a:defRPr sz="1200" b="0">
+                <a:solidFill>
+                  <a:srgbClr val="334155"/>
+                </a:solidFill>
+              </a:defRPr>
+            </a:pPr>
+            <a:r>
+              <a:rPr sz="1200" b="0">
+                <a:solidFill>
+                  <a:srgbClr val="334155"/>
+                </a:solidFill>
+              </a:rPr>
+              <a:t>Streaming changes when output appears, not whether the answer is grounded.</a:t>
+            </a:r>
+          </a:p>
+        </p:txBody>
+      </p:sp>
+      <p:sp>
+        <p:nvSpPr>
+          <p:cNvPr id="12" name="quiz-answer-3">
+            <a:extLst xmlns:a="http://schemas.openxmlformats.org/drawingml/2006/main">
+              <a:ext uri="{FF2B5EF4-FFF2-40B4-BE49-F238E27FC236}">
+                <a16:creationId xmlns:a16="http://schemas.microsoft.com/office/drawing/2014/main" id="{555D52B7-D7E5-4BB9-8818-7ED7557C5636}"/>
+              </a:ext>
+            </a:extLst>
+          </p:cNvPr>
+          <p:cNvSpPr>
+            <a:spLocks xmlns:a="http://schemas.openxmlformats.org/drawingml/2006/main" noGrp="1"/>
+          </p:cNvSpPr>
+          <p:nvPr/>
+        </p:nvSpPr>
+        <p:spPr>
+          <a:xfrm xmlns:a="http://schemas.openxmlformats.org/drawingml/2006/main">
+            <a:off x="971550" y="5772150"/>
+            <a:ext cx="13296900" cy="285750"/>
+          </a:xfrm>
+          <a:prstGeom xmlns:a="http://schemas.openxmlformats.org/drawingml/2006/main" prst="rect">
+            <a:avLst/>
+          </a:prstGeom>
+          <a:noFill xmlns:a="http://schemas.openxmlformats.org/drawingml/2006/main"/>
+          <a:ln xmlns:a="http://schemas.openxmlformats.org/drawingml/2006/main" w="0">
+            <a:noFill/>
+            <a:prstDash val="solid"/>
+          </a:ln>
+        </p:spPr>
+        <p:txBody>
+          <a:bodyPr xmlns:a="http://schemas.openxmlformats.org/drawingml/2006/main"/>
+          <a:lstStyle xmlns:a="http://schemas.openxmlformats.org/drawingml/2006/main"/>
+          <a:p xmlns:a="http://schemas.openxmlformats.org/drawingml/2006/main">
+            <a:pPr>
+              <a:defRPr sz="1500" b="1">
+                <a:solidFill>
+                  <a:srgbClr val="1F40CB"/>
+                </a:solidFill>
+              </a:defRPr>
+            </a:pPr>
+            <a:r>
+              <a:rPr sz="1500" b="1">
+                <a:solidFill>
+                  <a:srgbClr val="1F40CB"/>
+                </a:solidFill>
+              </a:rPr>
+              <a:t>3. B. None</a:t>
+            </a:r>
+          </a:p>
+        </p:txBody>
+      </p:sp>
+      <p:sp>
+        <p:nvSpPr>
+          <p:cNvPr id="13" name="quiz-explanation-3">
+            <a:extLst xmlns:a="http://schemas.openxmlformats.org/drawingml/2006/main">
+              <a:ext uri="{FF2B5EF4-FFF2-40B4-BE49-F238E27FC236}">
+                <a16:creationId xmlns:a16="http://schemas.microsoft.com/office/drawing/2014/main" id="{0196E178-EF1C-4FC5-852F-64D157DA77E5}"/>
+              </a:ext>
+            </a:extLst>
+          </p:cNvPr>
+          <p:cNvSpPr>
+            <a:spLocks xmlns:a="http://schemas.openxmlformats.org/drawingml/2006/main" noGrp="1"/>
+          </p:cNvSpPr>
+          <p:nvPr/>
+        </p:nvSpPr>
+        <p:spPr>
+          <a:xfrm xmlns:a="http://schemas.openxmlformats.org/drawingml/2006/main">
+            <a:off x="1257300" y="6076950"/>
+            <a:ext cx="13011150" cy="247650"/>
+          </a:xfrm>
+          <a:prstGeom xmlns:a="http://schemas.openxmlformats.org/drawingml/2006/main" prst="rect">
+            <a:avLst/>
+          </a:prstGeom>
+          <a:noFill xmlns:a="http://schemas.openxmlformats.org/drawingml/2006/main"/>
+          <a:ln xmlns:a="http://schemas.openxmlformats.org/drawingml/2006/main" w="0">
+            <a:noFill/>
+            <a:prstDash val="solid"/>
+          </a:ln>
+        </p:spPr>
+        <p:txBody>
+          <a:bodyPr xmlns:a="http://schemas.openxmlformats.org/drawingml/2006/main"/>
+          <a:lstStyle xmlns:a="http://schemas.openxmlformats.org/drawingml/2006/main"/>
+          <a:p xmlns:a="http://schemas.openxmlformats.org/drawingml/2006/main">
+            <a:pPr>
+              <a:defRPr sz="1200" b="0">
+                <a:solidFill>
+                  <a:srgbClr val="334155"/>
+                </a:solidFill>
+              </a:defRPr>
+            </a:pPr>
+            <a:r>
+              <a:rPr sz="1200" b="0">
+                <a:solidFill>
+                  <a:srgbClr val="334155"/>
+                </a:solidFill>
+              </a:rPr>
+              <a:t>Missing metadata stays unknown instead of becoming an invented number.</a:t>
+            </a:r>
+          </a:p>
+        </p:txBody>
+      </p:sp>
+    </p:spTree>
+    <p:extLst>
+      <p:ext uri="{BB962C8B-B14F-4D97-AF65-F5344CB8AC3E}">
+        <p14:creationId xmlns:p14="http://schemas.microsoft.com/office/powerpoint/2010/main" val="767502565"/>
+      </p:ext>
+    </p:extLst>
+  </p:cSld>
+</p:sld>
+</file>
+
 <file path=ppt/theme/theme1.xml><?xml version="1.0" encoding="utf-8"?>
 <a:theme xmlns:a="http://schemas.openxmlformats.org/drawingml/2006/main" name="ChatGPT">
   <a:themeElements>

</xml_diff>